<commit_message>
explored sp level data
</commit_message>
<xml_diff>
--- a/spillover_3_19_25.pptx
+++ b/spillover_3_19_25.pptx
@@ -5,17 +5,18 @@
     <p:sldMasterId id="2147483648" r:id="rId1"/>
   </p:sldMasterIdLst>
   <p:notesMasterIdLst>
-    <p:notesMasterId r:id="rId10"/>
+    <p:notesMasterId r:id="rId11"/>
   </p:notesMasterIdLst>
   <p:sldIdLst>
     <p:sldId id="256" r:id="rId2"/>
     <p:sldId id="331" r:id="rId3"/>
     <p:sldId id="332" r:id="rId4"/>
-    <p:sldId id="333" r:id="rId5"/>
-    <p:sldId id="334" r:id="rId6"/>
-    <p:sldId id="335" r:id="rId7"/>
-    <p:sldId id="336" r:id="rId8"/>
-    <p:sldId id="337" r:id="rId9"/>
+    <p:sldId id="338" r:id="rId5"/>
+    <p:sldId id="333" r:id="rId6"/>
+    <p:sldId id="334" r:id="rId7"/>
+    <p:sldId id="335" r:id="rId8"/>
+    <p:sldId id="336" r:id="rId9"/>
+    <p:sldId id="337" r:id="rId10"/>
   </p:sldIdLst>
   <p:sldSz cx="12192000" cy="6858000"/>
   <p:notesSz cx="6858000" cy="9144000"/>
@@ -114,6 +115,11 @@
       </a:defRPr>
     </a:lvl9pPr>
   </p:defaultTextStyle>
+  <p:extLst>
+    <p:ext uri="{EFAFB233-063F-42B5-8137-9DF3F51BA10A}">
+      <p15:sldGuideLst xmlns:p15="http://schemas.microsoft.com/office/powerpoint/2012/main"/>
+    </p:ext>
+  </p:extLst>
 </p:presentation>
 </file>
 
@@ -199,7 +205,7 @@
           <a:p>
             <a:fld id="{6915157A-D857-1446-AB3B-3E42BB38D85C}" type="datetimeFigureOut">
               <a:rPr lang="en-US" smtClean="0"/>
-              <a:t>3/19/25</a:t>
+              <a:t>3/20/25</a:t>
             </a:fld>
             <a:endParaRPr lang="en-US"/>
           </a:p>
@@ -708,7 +714,7 @@
           <a:p>
             <a:fld id="{6B9534BD-3754-2D48-B45E-F84A378186E2}" type="slidenum">
               <a:rPr lang="en-US" smtClean="0"/>
-              <a:t>4</a:t>
+              <a:t>5</a:t>
             </a:fld>
             <a:endParaRPr lang="en-US"/>
           </a:p>
@@ -795,7 +801,7 @@
           <a:p>
             <a:fld id="{6B9534BD-3754-2D48-B45E-F84A378186E2}" type="slidenum">
               <a:rPr lang="en-US" smtClean="0"/>
-              <a:t>5</a:t>
+              <a:t>6</a:t>
             </a:fld>
             <a:endParaRPr lang="en-US"/>
           </a:p>
@@ -906,7 +912,7 @@
           <a:p>
             <a:fld id="{6B9534BD-3754-2D48-B45E-F84A378186E2}" type="slidenum">
               <a:rPr lang="en-US" smtClean="0"/>
-              <a:t>6</a:t>
+              <a:t>7</a:t>
             </a:fld>
             <a:endParaRPr lang="en-US"/>
           </a:p>
@@ -1017,7 +1023,7 @@
           <a:p>
             <a:fld id="{6B9534BD-3754-2D48-B45E-F84A378186E2}" type="slidenum">
               <a:rPr lang="en-US" smtClean="0"/>
-              <a:t>7</a:t>
+              <a:t>8</a:t>
             </a:fld>
             <a:endParaRPr lang="en-US"/>
           </a:p>
@@ -1183,7 +1189,7 @@
           <a:p>
             <a:fld id="{D48CD3F4-70E9-FA41-9C2A-B10BCFF6AD7C}" type="datetimeFigureOut">
               <a:rPr lang="en-US" smtClean="0"/>
-              <a:t>3/19/25</a:t>
+              <a:t>3/20/25</a:t>
             </a:fld>
             <a:endParaRPr lang="en-US"/>
           </a:p>
@@ -1381,7 +1387,7 @@
           <a:p>
             <a:fld id="{D48CD3F4-70E9-FA41-9C2A-B10BCFF6AD7C}" type="datetimeFigureOut">
               <a:rPr lang="en-US" smtClean="0"/>
-              <a:t>3/19/25</a:t>
+              <a:t>3/20/25</a:t>
             </a:fld>
             <a:endParaRPr lang="en-US"/>
           </a:p>
@@ -1589,7 +1595,7 @@
           <a:p>
             <a:fld id="{D48CD3F4-70E9-FA41-9C2A-B10BCFF6AD7C}" type="datetimeFigureOut">
               <a:rPr lang="en-US" smtClean="0"/>
-              <a:t>3/19/25</a:t>
+              <a:t>3/20/25</a:t>
             </a:fld>
             <a:endParaRPr lang="en-US"/>
           </a:p>
@@ -1787,7 +1793,7 @@
           <a:p>
             <a:fld id="{D48CD3F4-70E9-FA41-9C2A-B10BCFF6AD7C}" type="datetimeFigureOut">
               <a:rPr lang="en-US" smtClean="0"/>
-              <a:t>3/19/25</a:t>
+              <a:t>3/20/25</a:t>
             </a:fld>
             <a:endParaRPr lang="en-US"/>
           </a:p>
@@ -2062,7 +2068,7 @@
           <a:p>
             <a:fld id="{D48CD3F4-70E9-FA41-9C2A-B10BCFF6AD7C}" type="datetimeFigureOut">
               <a:rPr lang="en-US" smtClean="0"/>
-              <a:t>3/19/25</a:t>
+              <a:t>3/20/25</a:t>
             </a:fld>
             <a:endParaRPr lang="en-US"/>
           </a:p>
@@ -2327,7 +2333,7 @@
           <a:p>
             <a:fld id="{D48CD3F4-70E9-FA41-9C2A-B10BCFF6AD7C}" type="datetimeFigureOut">
               <a:rPr lang="en-US" smtClean="0"/>
-              <a:t>3/19/25</a:t>
+              <a:t>3/20/25</a:t>
             </a:fld>
             <a:endParaRPr lang="en-US"/>
           </a:p>
@@ -2739,7 +2745,7 @@
           <a:p>
             <a:fld id="{D48CD3F4-70E9-FA41-9C2A-B10BCFF6AD7C}" type="datetimeFigureOut">
               <a:rPr lang="en-US" smtClean="0"/>
-              <a:t>3/19/25</a:t>
+              <a:t>3/20/25</a:t>
             </a:fld>
             <a:endParaRPr lang="en-US"/>
           </a:p>
@@ -2880,7 +2886,7 @@
           <a:p>
             <a:fld id="{D48CD3F4-70E9-FA41-9C2A-B10BCFF6AD7C}" type="datetimeFigureOut">
               <a:rPr lang="en-US" smtClean="0"/>
-              <a:t>3/19/25</a:t>
+              <a:t>3/20/25</a:t>
             </a:fld>
             <a:endParaRPr lang="en-US"/>
           </a:p>
@@ -2993,7 +2999,7 @@
           <a:p>
             <a:fld id="{D48CD3F4-70E9-FA41-9C2A-B10BCFF6AD7C}" type="datetimeFigureOut">
               <a:rPr lang="en-US" smtClean="0"/>
-              <a:t>3/19/25</a:t>
+              <a:t>3/20/25</a:t>
             </a:fld>
             <a:endParaRPr lang="en-US"/>
           </a:p>
@@ -3304,7 +3310,7 @@
           <a:p>
             <a:fld id="{D48CD3F4-70E9-FA41-9C2A-B10BCFF6AD7C}" type="datetimeFigureOut">
               <a:rPr lang="en-US" smtClean="0"/>
-              <a:t>3/19/25</a:t>
+              <a:t>3/20/25</a:t>
             </a:fld>
             <a:endParaRPr lang="en-US"/>
           </a:p>
@@ -3592,7 +3598,7 @@
           <a:p>
             <a:fld id="{D48CD3F4-70E9-FA41-9C2A-B10BCFF6AD7C}" type="datetimeFigureOut">
               <a:rPr lang="en-US" smtClean="0"/>
-              <a:t>3/19/25</a:t>
+              <a:t>3/20/25</a:t>
             </a:fld>
             <a:endParaRPr lang="en-US"/>
           </a:p>
@@ -3833,7 +3839,7 @@
           <a:p>
             <a:fld id="{D48CD3F4-70E9-FA41-9C2A-B10BCFF6AD7C}" type="datetimeFigureOut">
               <a:rPr lang="en-US" smtClean="0"/>
-              <a:t>3/19/25</a:t>
+              <a:t>3/20/25</a:t>
             </a:fld>
             <a:endParaRPr lang="en-US"/>
           </a:p>
@@ -4756,10 +4762,10 @@
       </p:grpSpPr>
       <p:pic>
         <p:nvPicPr>
-          <p:cNvPr id="5" name="Picture 4" descr="A graph with colored lines and dots&#10;&#10;AI-generated content may be incorrect.">
-            <a:extLst>
-              <a:ext uri="{FF2B5EF4-FFF2-40B4-BE49-F238E27FC236}">
-                <a16:creationId xmlns:a16="http://schemas.microsoft.com/office/drawing/2014/main" id="{1FB2104C-A3EA-1F4A-135A-88619B31B635}"/>
+          <p:cNvPr id="5" name="Picture 4">
+            <a:extLst>
+              <a:ext uri="{FF2B5EF4-FFF2-40B4-BE49-F238E27FC236}">
+                <a16:creationId xmlns:a16="http://schemas.microsoft.com/office/drawing/2014/main" id="{4EC57BD8-657B-942B-8E16-A5AEF5101DD5}"/>
               </a:ext>
             </a:extLst>
           </p:cNvPr>
@@ -4769,53 +4775,25 @@
           <p:nvPr/>
         </p:nvPicPr>
         <p:blipFill>
-          <a:blip r:embed="rId3"/>
-          <a:srcRect l="1468"/>
-          <a:stretch/>
-        </p:blipFill>
-        <p:spPr>
-          <a:xfrm>
-            <a:off x="2496456" y="317500"/>
-            <a:ext cx="7307943" cy="6223000"/>
-          </a:xfrm>
-          <a:prstGeom prst="rect">
-            <a:avLst/>
-          </a:prstGeom>
-        </p:spPr>
-      </p:pic>
-      <p:pic>
-        <p:nvPicPr>
-          <p:cNvPr id="6" name="Content Placeholder 4" descr="A screenshot of a chart&#10;&#10;AI-generated content may be incorrect.">
-            <a:extLst>
-              <a:ext uri="{FF2B5EF4-FFF2-40B4-BE49-F238E27FC236}">
-                <a16:creationId xmlns:a16="http://schemas.microsoft.com/office/drawing/2014/main" id="{279AE271-F5BB-0493-3B02-2E0745B63EFF}"/>
-              </a:ext>
-            </a:extLst>
-          </p:cNvPr>
-          <p:cNvPicPr>
-            <a:picLocks noGrp="1" noChangeAspect="1"/>
-          </p:cNvPicPr>
-          <p:nvPr>
-            <p:ph idx="1"/>
-          </p:nvPr>
-        </p:nvPicPr>
-        <p:blipFill>
-          <a:blip r:embed="rId4"/>
+          <a:blip r:embed="rId2"/>
           <a:stretch>
             <a:fillRect/>
           </a:stretch>
         </p:blipFill>
         <p:spPr>
           <a:xfrm>
-            <a:off x="935762" y="422955"/>
-            <a:ext cx="9566828" cy="6012089"/>
-          </a:xfrm>
+            <a:off x="2298700" y="266700"/>
+            <a:ext cx="7594600" cy="6324600"/>
+          </a:xfrm>
+          <a:prstGeom prst="rect">
+            <a:avLst/>
+          </a:prstGeom>
         </p:spPr>
       </p:pic>
     </p:spTree>
     <p:extLst>
       <p:ext uri="{BB962C8B-B14F-4D97-AF65-F5344CB8AC3E}">
-        <p14:creationId xmlns:p14="http://schemas.microsoft.com/office/powerpoint/2010/main" val="1058293066"/>
+        <p14:creationId xmlns:p14="http://schemas.microsoft.com/office/powerpoint/2010/main" val="3719011424"/>
       </p:ext>
     </p:extLst>
   </p:cSld>
@@ -4844,6 +4822,94 @@
       </p:grpSpPr>
       <p:pic>
         <p:nvPicPr>
+          <p:cNvPr id="5" name="Picture 4" descr="A graph with colored lines and dots&#10;&#10;AI-generated content may be incorrect.">
+            <a:extLst>
+              <a:ext uri="{FF2B5EF4-FFF2-40B4-BE49-F238E27FC236}">
+                <a16:creationId xmlns:a16="http://schemas.microsoft.com/office/drawing/2014/main" id="{1FB2104C-A3EA-1F4A-135A-88619B31B635}"/>
+              </a:ext>
+            </a:extLst>
+          </p:cNvPr>
+          <p:cNvPicPr>
+            <a:picLocks noChangeAspect="1"/>
+          </p:cNvPicPr>
+          <p:nvPr/>
+        </p:nvPicPr>
+        <p:blipFill>
+          <a:blip r:embed="rId3"/>
+          <a:srcRect l="1468"/>
+          <a:stretch/>
+        </p:blipFill>
+        <p:spPr>
+          <a:xfrm>
+            <a:off x="2496456" y="317500"/>
+            <a:ext cx="7307943" cy="6223000"/>
+          </a:xfrm>
+          <a:prstGeom prst="rect">
+            <a:avLst/>
+          </a:prstGeom>
+        </p:spPr>
+      </p:pic>
+      <p:pic>
+        <p:nvPicPr>
+          <p:cNvPr id="6" name="Content Placeholder 4" descr="A screenshot of a chart&#10;&#10;AI-generated content may be incorrect.">
+            <a:extLst>
+              <a:ext uri="{FF2B5EF4-FFF2-40B4-BE49-F238E27FC236}">
+                <a16:creationId xmlns:a16="http://schemas.microsoft.com/office/drawing/2014/main" id="{279AE271-F5BB-0493-3B02-2E0745B63EFF}"/>
+              </a:ext>
+            </a:extLst>
+          </p:cNvPr>
+          <p:cNvPicPr>
+            <a:picLocks noGrp="1" noChangeAspect="1"/>
+          </p:cNvPicPr>
+          <p:nvPr>
+            <p:ph idx="1"/>
+          </p:nvPr>
+        </p:nvPicPr>
+        <p:blipFill>
+          <a:blip r:embed="rId4"/>
+          <a:stretch>
+            <a:fillRect/>
+          </a:stretch>
+        </p:blipFill>
+        <p:spPr>
+          <a:xfrm>
+            <a:off x="935762" y="422955"/>
+            <a:ext cx="9566828" cy="6012089"/>
+          </a:xfrm>
+        </p:spPr>
+      </p:pic>
+    </p:spTree>
+    <p:extLst>
+      <p:ext uri="{BB962C8B-B14F-4D97-AF65-F5344CB8AC3E}">
+        <p14:creationId xmlns:p14="http://schemas.microsoft.com/office/powerpoint/2010/main" val="1058293066"/>
+      </p:ext>
+    </p:extLst>
+  </p:cSld>
+  <p:clrMapOvr>
+    <a:masterClrMapping/>
+  </p:clrMapOvr>
+</p:sld>
+</file>
+
+<file path=ppt/slides/slide6.xml><?xml version="1.0" encoding="utf-8"?>
+<p:sld xmlns:a="http://schemas.openxmlformats.org/drawingml/2006/main" xmlns:r="http://schemas.openxmlformats.org/officeDocument/2006/relationships" xmlns:p="http://schemas.openxmlformats.org/presentationml/2006/main">
+  <p:cSld>
+    <p:spTree>
+      <p:nvGrpSpPr>
+        <p:cNvPr id="1" name=""/>
+        <p:cNvGrpSpPr/>
+        <p:nvPr/>
+      </p:nvGrpSpPr>
+      <p:grpSpPr>
+        <a:xfrm>
+          <a:off x="0" y="0"/>
+          <a:ext cx="0" cy="0"/>
+          <a:chOff x="0" y="0"/>
+          <a:chExt cx="0" cy="0"/>
+        </a:xfrm>
+      </p:grpSpPr>
+      <p:pic>
+        <p:nvPicPr>
           <p:cNvPr id="5" name="Content Placeholder 4" descr="A screenshot of a chart&#10;&#10;AI-generated content may be incorrect.">
             <a:extLst>
               <a:ext uri="{FF2B5EF4-FFF2-40B4-BE49-F238E27FC236}">
@@ -5027,7 +5093,7 @@
 </p:sld>
 </file>
 
-<file path=ppt/slides/slide6.xml><?xml version="1.0" encoding="utf-8"?>
+<file path=ppt/slides/slide7.xml><?xml version="1.0" encoding="utf-8"?>
 <p:sld xmlns:a="http://schemas.openxmlformats.org/drawingml/2006/main" xmlns:r="http://schemas.openxmlformats.org/officeDocument/2006/relationships" xmlns:p="http://schemas.openxmlformats.org/presentationml/2006/main">
   <p:cSld>
     <p:spTree>
@@ -5566,6 +5632,110 @@
           </a:p>
         </p:txBody>
       </p:sp>
+      <p:sp>
+        <p:nvSpPr>
+          <p:cNvPr id="13" name="Rectangle 12">
+            <a:extLst>
+              <a:ext uri="{FF2B5EF4-FFF2-40B4-BE49-F238E27FC236}">
+                <a16:creationId xmlns:a16="http://schemas.microsoft.com/office/drawing/2014/main" id="{89E0098D-C6FA-2A89-5B05-FBB5EABBADDD}"/>
+              </a:ext>
+            </a:extLst>
+          </p:cNvPr>
+          <p:cNvSpPr/>
+          <p:nvPr/>
+        </p:nvSpPr>
+        <p:spPr>
+          <a:xfrm>
+            <a:off x="1014761" y="422164"/>
+            <a:ext cx="1550019" cy="1027495"/>
+          </a:xfrm>
+          <a:prstGeom prst="rect">
+            <a:avLst/>
+          </a:prstGeom>
+          <a:noFill/>
+          <a:ln w="57150">
+            <a:solidFill>
+              <a:srgbClr val="C00000"/>
+            </a:solidFill>
+          </a:ln>
+        </p:spPr>
+        <p:style>
+          <a:lnRef idx="2">
+            <a:schemeClr val="accent1">
+              <a:shade val="15000"/>
+            </a:schemeClr>
+          </a:lnRef>
+          <a:fillRef idx="1">
+            <a:schemeClr val="accent1"/>
+          </a:fillRef>
+          <a:effectRef idx="0">
+            <a:schemeClr val="accent1"/>
+          </a:effectRef>
+          <a:fontRef idx="minor">
+            <a:schemeClr val="lt1"/>
+          </a:fontRef>
+        </p:style>
+        <p:txBody>
+          <a:bodyPr rtlCol="0" anchor="ctr"/>
+          <a:lstStyle/>
+          <a:p>
+            <a:pPr algn="ctr"/>
+            <a:endParaRPr lang="en-US"/>
+          </a:p>
+        </p:txBody>
+      </p:sp>
+      <p:sp>
+        <p:nvSpPr>
+          <p:cNvPr id="14" name="Rectangle 13">
+            <a:extLst>
+              <a:ext uri="{FF2B5EF4-FFF2-40B4-BE49-F238E27FC236}">
+                <a16:creationId xmlns:a16="http://schemas.microsoft.com/office/drawing/2014/main" id="{196BBF12-9C0F-3A4C-9DC7-65F7640AB78C}"/>
+              </a:ext>
+            </a:extLst>
+          </p:cNvPr>
+          <p:cNvSpPr/>
+          <p:nvPr/>
+        </p:nvSpPr>
+        <p:spPr>
+          <a:xfrm>
+            <a:off x="8788045" y="3295462"/>
+            <a:ext cx="1550019" cy="1027495"/>
+          </a:xfrm>
+          <a:prstGeom prst="rect">
+            <a:avLst/>
+          </a:prstGeom>
+          <a:noFill/>
+          <a:ln w="57150">
+            <a:solidFill>
+              <a:srgbClr val="C00000"/>
+            </a:solidFill>
+          </a:ln>
+        </p:spPr>
+        <p:style>
+          <a:lnRef idx="2">
+            <a:schemeClr val="accent1">
+              <a:shade val="15000"/>
+            </a:schemeClr>
+          </a:lnRef>
+          <a:fillRef idx="1">
+            <a:schemeClr val="accent1"/>
+          </a:fillRef>
+          <a:effectRef idx="0">
+            <a:schemeClr val="accent1"/>
+          </a:effectRef>
+          <a:fontRef idx="minor">
+            <a:schemeClr val="lt1"/>
+          </a:fontRef>
+        </p:style>
+        <p:txBody>
+          <a:bodyPr rtlCol="0" anchor="ctr"/>
+          <a:lstStyle/>
+          <a:p>
+            <a:pPr algn="ctr"/>
+            <a:endParaRPr lang="en-US"/>
+          </a:p>
+        </p:txBody>
+      </p:sp>
     </p:spTree>
     <p:extLst>
       <p:ext uri="{BB962C8B-B14F-4D97-AF65-F5344CB8AC3E}">
@@ -5579,7 +5749,7 @@
 </p:sld>
 </file>
 
-<file path=ppt/slides/slide7.xml><?xml version="1.0" encoding="utf-8"?>
+<file path=ppt/slides/slide8.xml><?xml version="1.0" encoding="utf-8"?>
 <p:sld xmlns:a="http://schemas.openxmlformats.org/drawingml/2006/main" xmlns:r="http://schemas.openxmlformats.org/officeDocument/2006/relationships" xmlns:p="http://schemas.openxmlformats.org/presentationml/2006/main">
   <p:cSld>
     <p:spTree>
@@ -6132,7 +6302,7 @@
 </p:sld>
 </file>
 
-<file path=ppt/slides/slide8.xml><?xml version="1.0" encoding="utf-8"?>
+<file path=ppt/slides/slide9.xml><?xml version="1.0" encoding="utf-8"?>
 <p:sld xmlns:a="http://schemas.openxmlformats.org/drawingml/2006/main" xmlns:r="http://schemas.openxmlformats.org/officeDocument/2006/relationships" xmlns:p="http://schemas.openxmlformats.org/presentationml/2006/main">
   <p:cSld>
     <p:spTree>

</xml_diff>